<commit_message>
Define politicas proprias do grupo e revisa experimentos/apresentacao
- Substitui os placeholders de politica por duas politicas do grupo:
  "Imita o dealer (>=17)" e "Depende da carta do dealer" (para em 12
  contra dealer fraco 2-5), com First-Visit MC recalculado (200k
  episodios) e resultados atualizados em resultados/.
- Adiciona guia explicativo dos experimentos para leigos (docs/,
  versoes .md e .html).
- Revisa a apresentacao (v2) com os novos numeros/graficos e cria v3
  com ajustes de storytelling: notas do apresentador corrigidas,
  slide de politicas aprendidas recalculado contra as politicas atuais,
  nova slide comparando as duas politicas do grupo lado a lado.
- Gera visuais novos de apoio (heatmaps de decisao/V(s), divergencia,
  grafico animado) em resultados/.
</commit_message>
<xml_diff>
--- a/apresentacao/Apresentacao_Monte_Carlo_AC2_v2.pptx
+++ b/apresentacao/Apresentacao_Monte_Carlo_AC2_v2.pptx
@@ -17,6 +17,7 @@
     <p:sldId id="265" r:id="rId11"/>
     <p:sldId id="266" r:id="rId12"/>
     <p:sldId id="267" r:id="rId13"/>
+    <p:sldId id="279" r:id="rId30"/>
     <p:sldId id="268" r:id="rId14"/>
     <p:sldId id="269" r:id="rId15"/>
     <p:sldId id="270" r:id="rId16"/>
@@ -267,26 +268,24 @@
             <c:showLeaderLines val="0"/>
           </c:dLbls>
           <c:cat>
-            <c:multiLvlStrRef>
+            <c:strRef>
               <c:f>Sheet1!$A$2:$A$5</c:f>
-              <c:multiLvlStrCache>
+              <c:strCache>
                 <c:ptCount val="4"/>
-                <c:lvl>
-                  <c:pt idx="0">
-                    <c:v>Estratégia básica</c:v>
-                  </c:pt>
-                  <c:pt idx="1">
-                    <c:v>Conservadora ≥17</c:v>
-                  </c:pt>
-                  <c:pt idx="2">
-                    <c:v>Simples ≥20 (professor)</c:v>
-                  </c:pt>
-                  <c:pt idx="3">
-                    <c:v>Aleatória 50/50</c:v>
-                  </c:pt>
-                </c:lvl>
-              </c:multiLvlStrCache>
-            </c:multiLvlStrRef>
+                <c:pt idx="0">
+                  <c:v>Carta do dealer</c:v>
+                </c:pt>
+                <c:pt idx="1">
+                  <c:v>Imita o dealer</c:v>
+                </c:pt>
+                <c:pt idx="2">
+                  <c:v>Simples ≥20</c:v>
+                </c:pt>
+                <c:pt idx="3">
+                  <c:v>Aleatória 50/50</c:v>
+                </c:pt>
+              </c:strCache>
+            </c:strRef>
           </c:cat>
           <c:val>
             <c:numRef>
@@ -295,7 +294,7 @@
                 <c:formatCode>General</c:formatCode>
                 <c:ptCount val="4"/>
                 <c:pt idx="0">
-                  <c:v>-0.0406</c:v>
+                  <c:v>-0.0592</c:v>
                 </c:pt>
                 <c:pt idx="1">
                   <c:v>-0.0728</c:v>
@@ -304,7 +303,7 @@
                   <c:v>-0.3519</c:v>
                 </c:pt>
                 <c:pt idx="3">
-                  <c:v>-0.3962</c:v>
+                  <c:v>-0.3945</c:v>
                 </c:pt>
               </c:numCache>
             </c:numRef>
@@ -5049,7 +5048,7 @@
                           <a:ea typeface="Calibri" pitchFamily="34" charset="-122"/>
                           <a:cs typeface="Calibri" pitchFamily="34" charset="-120"/>
                         </a:rPr>
-                        <a:t>Estratégia básica</a:t>
+                        <a:t>Depende da carta do dealer</a:t>
                       </a:r>
                       <a:endParaRPr lang="en-US" sz="1400" dirty="0">
                         <a:latin typeface="Calibri" charset="0"/>
@@ -5093,7 +5092,7 @@
                           <a:ea typeface="Calibri" pitchFamily="34" charset="-122"/>
                           <a:cs typeface="Calibri" pitchFamily="34" charset="-120"/>
                         </a:rPr>
-                        <a:t>Regra clássica: tabelas de HIT/STICK por soma, carta do dealer e ás.</a:t>
+                        <a:t>Se a carta do dealer está entre 2 e 5 (mesa fraca), para com soma ≥ 12; com qualquer outra carta, para com soma ≥ 17.</a:t>
                       </a:r>
                       <a:endParaRPr lang="en-US" sz="1400" dirty="0">
                         <a:latin typeface="Calibri" charset="0"/>
@@ -5139,7 +5138,7 @@
                           <a:ea typeface="Calibri" pitchFamily="34" charset="-122"/>
                           <a:cs typeface="Calibri" pitchFamily="34" charset="-120"/>
                         </a:rPr>
-                        <a:t>Conservadora ≥17</a:t>
+                        <a:t>Imita o dealer (≥17)</a:t>
                       </a:r>
                       <a:endParaRPr lang="en-US" sz="1400" dirty="0">
                         <a:latin typeface="Calibri" charset="0"/>
@@ -5183,7 +5182,7 @@
                           <a:ea typeface="Calibri" pitchFamily="34" charset="-122"/>
                           <a:cs typeface="Calibri" pitchFamily="34" charset="-120"/>
                         </a:rPr>
-                        <a:t>Para com soma ≥ 17, pede carta caso contrário.</a:t>
+                        <a:t>Para com soma ≥ 17, pede carta caso contrário — a mesma regra usada pelo próprio dealer.</a:t>
                       </a:r>
                       <a:endParaRPr lang="en-US" sz="1400" dirty="0">
                         <a:latin typeface="Calibri" charset="0"/>
@@ -5788,7 +5787,7 @@
                           <a:ea typeface="Calibri" pitchFamily="34" charset="-122"/>
                           <a:cs typeface="Calibri" pitchFamily="34" charset="-120"/>
                         </a:rPr>
-                        <a:t>Estratégia básica</a:t>
+                        <a:t>Depende da carta do dealer</a:t>
                       </a:r>
                       <a:endParaRPr lang="en-US" sz="1400" dirty="0">
                         <a:latin typeface="Calibri" charset="0"/>
@@ -5832,7 +5831,7 @@
                           <a:ea typeface="Calibri" pitchFamily="34" charset="-122"/>
                           <a:cs typeface="Calibri" pitchFamily="34" charset="-120"/>
                         </a:rPr>
-                        <a:t>43,5%</a:t>
+                        <a:t>42,5%</a:t>
                       </a:r>
                       <a:endParaRPr lang="en-US" sz="1400" dirty="0">
                         <a:latin typeface="Calibri" charset="0"/>
@@ -5876,7 +5875,7 @@
                           <a:ea typeface="Calibri" pitchFamily="34" charset="-122"/>
                           <a:cs typeface="Calibri" pitchFamily="34" charset="-120"/>
                         </a:rPr>
-                        <a:t>9,0%</a:t>
+                        <a:t>9,2%</a:t>
                       </a:r>
                       <a:endParaRPr lang="en-US" sz="1400" dirty="0">
                         <a:latin typeface="Calibri" charset="0"/>
@@ -5920,7 +5919,7 @@
                           <a:ea typeface="Calibri" pitchFamily="34" charset="-122"/>
                           <a:cs typeface="Calibri" pitchFamily="34" charset="-120"/>
                         </a:rPr>
-                        <a:t>47,5%</a:t>
+                        <a:t>48,4%</a:t>
                       </a:r>
                       <a:endParaRPr lang="en-US" sz="1400" dirty="0">
                         <a:latin typeface="Calibri" charset="0"/>
@@ -5966,7 +5965,7 @@
                           <a:ea typeface="Calibri" pitchFamily="34" charset="-122"/>
                           <a:cs typeface="Calibri" pitchFamily="34" charset="-120"/>
                         </a:rPr>
-                        <a:t>Conservadora ≥17</a:t>
+                        <a:t>Imita o dealer (≥17)</a:t>
                       </a:r>
                       <a:endParaRPr lang="en-US" sz="1400" dirty="0">
                         <a:latin typeface="Calibri" charset="0"/>
@@ -6366,7 +6365,7 @@
                           <a:ea typeface="Calibri" pitchFamily="34" charset="-122"/>
                           <a:cs typeface="Calibri" pitchFamily="34" charset="-120"/>
                         </a:rPr>
-                        <a:t>28,1%</a:t>
+                        <a:t>28,2%</a:t>
                       </a:r>
                       <a:endParaRPr lang="en-US" sz="1400" dirty="0">
                         <a:latin typeface="Calibri" charset="0"/>
@@ -6519,7 +6518,7 @@
                 <a:ea typeface="Calibri" pitchFamily="34" charset="-122"/>
                 <a:cs typeface="Calibri" pitchFamily="34" charset="-120"/>
               </a:rPr>
-              <a:t>A estratégia básica fica -0,311 acima da política do professor, mas ainda perde em média: a vantagem estrutural é da banca.</a:t>
+              <a:t>"Depende da carta do dealer" melhora o retorno médio em 0,014 por partida frente a apenas "Imitar o dealer" — mas nenhuma das duas supera a banca (a vantagem estrutural é dela).</a:t>
             </a:r>
             <a:endParaRPr lang="en-US" sz="1400" dirty="0"/>
           </a:p>
@@ -6633,22 +6632,187 @@
                 <a:ea typeface="Cambria" pitchFamily="34" charset="-122"/>
                 <a:cs typeface="Cambria" pitchFamily="34" charset="-120"/>
               </a:rPr>
-              <a:t>V(s) estimado: estratégia básica × Simples ≥20</a:t>
+              <a:t>V(s) estimado: nossas duas políticas do grupo</a:t>
             </a:r>
             <a:endParaRPr lang="en-US" sz="3200" dirty="0"/>
           </a:p>
         </p:txBody>
       </p:sp>
+      <p:sp>
+        <p:nvSpPr>
+          <p:cNvPr id="6" name="Text 1"/>
+          <p:cNvSpPr txBox="1"/>
+          <p:nvPr/>
+        </p:nvSpPr>
+        <p:spPr>
+          <a:xfrm>
+            <a:off x="548640" y="4892040"/>
+            <a:ext cx="5486400" cy="365760"/>
+          </a:xfrm>
+          <a:prstGeom prst="rect">
+            <a:avLst/>
+          </a:prstGeom>
+          <a:noFill/>
+          <a:ln/>
+        </p:spPr>
+        <p:txBody>
+          <a:bodyPr wrap="square" lIns="0" tIns="0" rIns="0" bIns="0" rtlCol="0" anchor="ctr"/>
+          <a:lstStyle/>
+          <a:p>
+            <a:pPr algn="ctr" indent="0" marL="0">
+              <a:buNone/>
+            </a:pPr>
+            <a:r>
+              <a:rPr lang="en-US" sz="1600" b="1" dirty="0">
+                <a:solidFill>
+                  <a:srgbClr val="0B6E4F"/>
+                </a:solidFill>
+                <a:latin typeface="Cambria" pitchFamily="34" charset="0"/>
+                <a:ea typeface="Cambria" pitchFamily="34" charset="-122"/>
+                <a:cs typeface="Cambria" pitchFamily="34" charset="-120"/>
+              </a:rPr>
+              <a:t>Depende da carta do dealer</a:t>
+            </a:r>
+            <a:endParaRPr lang="en-US" sz="1600" dirty="0"/>
+          </a:p>
+        </p:txBody>
+      </p:sp>
+      <p:sp>
+        <p:nvSpPr>
+          <p:cNvPr id="7" name="Text 2"/>
+          <p:cNvSpPr txBox="1"/>
+          <p:nvPr/>
+        </p:nvSpPr>
+        <p:spPr>
+          <a:xfrm>
+            <a:off x="6263640" y="4892040"/>
+            <a:ext cx="5486400" cy="365760"/>
+          </a:xfrm>
+          <a:prstGeom prst="rect">
+            <a:avLst/>
+          </a:prstGeom>
+          <a:noFill/>
+          <a:ln/>
+        </p:spPr>
+        <p:txBody>
+          <a:bodyPr wrap="square" lIns="0" tIns="0" rIns="0" bIns="0" rtlCol="0" anchor="ctr"/>
+          <a:lstStyle/>
+          <a:p>
+            <a:pPr algn="ctr" indent="0" marL="0">
+              <a:buNone/>
+            </a:pPr>
+            <a:r>
+              <a:rPr lang="en-US" sz="1600" b="1" dirty="0">
+                <a:solidFill>
+                  <a:srgbClr val="3A6EA5"/>
+                </a:solidFill>
+                <a:latin typeface="Cambria" pitchFamily="34" charset="0"/>
+                <a:ea typeface="Cambria" pitchFamily="34" charset="-122"/>
+                <a:cs typeface="Cambria" pitchFamily="34" charset="-120"/>
+              </a:rPr>
+              <a:t>Imita o dealer (≥17)</a:t>
+            </a:r>
+            <a:endParaRPr lang="en-US" sz="1600" dirty="0"/>
+          </a:p>
+        </p:txBody>
+      </p:sp>
+      <p:sp>
+        <p:nvSpPr>
+          <p:cNvPr id="8" name="Text 3"/>
+          <p:cNvSpPr txBox="1"/>
+          <p:nvPr/>
+        </p:nvSpPr>
+        <p:spPr>
+          <a:xfrm>
+            <a:off x="548640" y="5349240"/>
+            <a:ext cx="11064240" cy="822960"/>
+          </a:xfrm>
+          <a:prstGeom prst="rect">
+            <a:avLst/>
+          </a:prstGeom>
+          <a:noFill/>
+          <a:ln/>
+        </p:spPr>
+        <p:txBody>
+          <a:bodyPr wrap="square" lIns="0" tIns="0" rIns="0" bIns="0" rtlCol="0" anchor="t"/>
+          <a:lstStyle/>
+          <a:p>
+            <a:pPr indent="0" marL="0">
+              <a:buNone/>
+            </a:pPr>
+            <a:r>
+              <a:rPr lang="en-US" sz="1400" dirty="0">
+                <a:solidFill>
+                  <a:schemeClr val="tx1"/>
+                </a:solidFill>
+                <a:latin typeface="Calibri" pitchFamily="34" charset="0"/>
+                <a:ea typeface="Calibri" pitchFamily="34" charset="-122"/>
+                <a:cs typeface="Calibri" pitchFamily="34" charset="-120"/>
+              </a:rPr>
+              <a:t>Contra dealer fraco (2–5), parar em 12 já é melhor que seguir até 17: p.ex. soma 15 vs. dealer 3, V(s) sobe de -0,42 para -0,25. Contra dealer forte as duas regras coincidem (mesmo V(s)); nenhuma das duas usa a informação de ás usável — por isso os dois painéis de cada política são praticamente iguais.</a:t>
+            </a:r>
+            <a:endParaRPr lang="en-US" sz="1400" dirty="0"/>
+          </a:p>
+        </p:txBody>
+      </p:sp>
+      <p:sp>
+        <p:nvSpPr>
+          <p:cNvPr id="25" name="Slide Number Placeholder 0"/>
+          <p:cNvSpPr>
+            <a:spLocks noGrp="1"/>
+          </p:cNvSpPr>
+          <p:nvPr>
+            <p:ph type="sldNum" sz="quarter" idx="4294967295"/>
+          </p:nvPr>
+        </p:nvSpPr>
+        <p:spPr>
+          <a:xfrm>
+            <a:off x="11247120" y="6446520"/>
+            <a:ext cx="548640" cy="274320"/>
+          </a:xfrm>
+          <a:prstGeom prst="rect">
+            <a:avLst/>
+          </a:prstGeom>
+          <a:extLst>
+            <a:ext uri="{C572A759-6A51-4108-AA02-DFA0A04FC94B}">
+              <ma14:wrappingTextBoxFlag xmlns:ma14="http://schemas.microsoft.com/office/mac/drawingml/2011/main" val="0"/>
+            </a:ext>
+          </a:extLst>
+        </p:spPr>
+        <p:txBody>
+          <a:bodyPr/>
+          <a:lstStyle>
+            <a:lvl1pPr>
+              <a:defRPr sz="1000">
+                <a:solidFill>
+                  <a:schemeClr val="tx2"/>
+                </a:solidFill>
+                <a:latin typeface="Calibri"/>
+                <a:ea typeface="Calibri"/>
+                <a:cs typeface="Calibri"/>
+              </a:defRPr>
+            </a:lvl1pPr>
+          </a:lstStyle>
+          <a:p>
+            <a:pPr algn="r"/>
+            <a:fld id="{F7021451-1387-4CA6-816F-3879F97B5CBC}" type="slidenum">
+              <a:rPr b="0" lang="en-US"/>
+              <a:t>12</a:t>
+            </a:fld>
+            <a:endParaRPr lang="en-US"/>
+          </a:p>
+        </p:txBody>
+      </p:sp>
       <p:pic>
         <p:nvPicPr>
-          <p:cNvPr id="4" name="heatmap V estratégia básica" descr="heatmap V estratégia básica">    </p:cNvPr>
+          <p:cNvPr id="26" name="Picture 25" descr="grupo_v_dealer_fraco.png"/>
           <p:cNvPicPr>
             <a:picLocks noChangeAspect="1"/>
           </p:cNvPicPr>
           <p:nvPr/>
         </p:nvPicPr>
         <p:blipFill>
-          <a:blip r:embed="rId1"/>
+          <a:blip r:embed="rId5"/>
           <a:stretch>
             <a:fillRect/>
           </a:stretch>
@@ -6665,14 +6829,14 @@
       </p:pic>
       <p:pic>
         <p:nvPicPr>
-          <p:cNvPr id="5" name="heatmap V simples 20" descr="heatmap V simples 20">    </p:cNvPr>
+          <p:cNvPr id="27" name="Picture 26" descr="grupo_v_imita_dealer.png"/>
           <p:cNvPicPr>
             <a:picLocks noChangeAspect="1"/>
           </p:cNvPicPr>
           <p:nvPr/>
         </p:nvPicPr>
         <p:blipFill>
-          <a:blip r:embed="rId2"/>
+          <a:blip r:embed="rId6"/>
           <a:stretch>
             <a:fillRect/>
           </a:stretch>
@@ -6687,16 +6851,106 @@
           </a:prstGeom>
         </p:spPr>
       </p:pic>
-      <p:sp>
-        <p:nvSpPr>
-          <p:cNvPr id="6" name="Text 1"/>
+    </p:spTree>
+  </p:cSld>
+  <p:clrMapOvr>
+    <a:masterClrMapping/>
+  </p:clrMapOvr>
+</p:sld>
+</file>
+
+<file path=ppt/slides/slide13.xml><?xml version="1.0" encoding="utf-8"?>
+<p:sld xmlns:a="http://schemas.openxmlformats.org/drawingml/2006/main" xmlns:p="http://schemas.openxmlformats.org/presentationml/2006/main" xmlns:r="http://schemas.openxmlformats.org/officeDocument/2006/relationships">
+  <p:cSld>
+    <p:spTree>
+      <p:nvGrpSpPr>
+        <p:cNvPr id="1" name=""/>
+        <p:cNvGrpSpPr/>
+        <p:nvPr/>
+      </p:nvGrpSpPr>
+      <p:grpSpPr/>
+      <p:sp>
+        <p:nvSpPr>
+          <p:cNvPr id="2" name="Title 1"/>
+          <p:cNvSpPr>
+            <a:spLocks noGrp="1"/>
+          </p:cNvSpPr>
+          <p:nvPr>
+            <p:ph type="title" idx="101"/>
+          </p:nvPr>
+        </p:nvSpPr>
+        <p:spPr/>
+        <p:txBody>
+          <a:bodyPr/>
+          <a:lstStyle/>
+          <a:p>
+            <a:r>
+              <a:t>Onde as duas políticas do grupo discordam</a:t>
+            </a:r>
+          </a:p>
+        </p:txBody>
+      </p:sp>
+      <p:pic>
+        <p:nvPicPr>
+          <p:cNvPr id="3" name="Picture 2" descr="grupo_diferenca_decisao.png"/>
+          <p:cNvPicPr>
+            <a:picLocks noChangeAspect="1"/>
+          </p:cNvPicPr>
+          <p:nvPr/>
+        </p:nvPicPr>
+        <p:blipFill>
+          <a:blip r:embed="rId2"/>
+          <a:stretch>
+            <a:fillRect/>
+          </a:stretch>
+        </p:blipFill>
+        <p:spPr>
+          <a:xfrm>
+            <a:off x="548640" y="1417320"/>
+            <a:ext cx="6309360" cy="4754880"/>
+          </a:xfrm>
+          <a:prstGeom prst="rect">
+            <a:avLst/>
+          </a:prstGeom>
+        </p:spPr>
+      </p:pic>
+      <p:sp>
+        <p:nvSpPr>
+          <p:cNvPr id="5" name="card Problema encontrado e corrigido"/>
+          <p:cNvSpPr/>
+          <p:nvPr/>
+        </p:nvSpPr>
+        <p:spPr>
+          <a:xfrm>
+            <a:off x="7132320" y="1417320"/>
+            <a:ext cx="4480560" cy="4754880"/>
+          </a:xfrm>
+          <a:prstGeom prst="roundRect">
+            <a:avLst>
+              <a:gd name="adj" fmla="val 4211"/>
+            </a:avLst>
+          </a:prstGeom>
+          <a:solidFill>
+            <a:schemeClr val="bg2"/>
+          </a:solidFill>
+          <a:ln w="12700">
+            <a:solidFill>
+              <a:schemeClr val="bg2"/>
+            </a:solidFill>
+            <a:prstDash val="solid"/>
+          </a:ln>
+        </p:spPr>
+      </p:sp>
+      <p:sp>
+        <p:nvSpPr>
+          <p:cNvPr id="6" name="Text 2"/>
           <p:cNvSpPr txBox="1"/>
           <p:nvPr/>
         </p:nvSpPr>
         <p:spPr>
           <a:xfrm>
-            <a:off x="548640" y="4892040"/>
-            <a:ext cx="5486400" cy="365760"/>
+            <a:off x="7315200" y="1554480"/>
+            <a:ext cx="4114800" cy="411480"/>
           </a:xfrm>
           <a:prstGeom prst="rect">
             <a:avLst/>
@@ -6708,46 +6962,7 @@
           <a:bodyPr wrap="square" lIns="0" tIns="0" rIns="0" bIns="0" rtlCol="0" anchor="ctr"/>
           <a:lstStyle/>
           <a:p>
-            <a:pPr algn="ctr" indent="0" marL="0">
-              <a:buNone/>
-            </a:pPr>
-            <a:r>
-              <a:rPr lang="en-US" sz="1600" b="1" dirty="0">
-                <a:solidFill>
-                  <a:srgbClr val="0B6E4F"/>
-                </a:solidFill>
-                <a:latin typeface="Cambria" pitchFamily="34" charset="0"/>
-                <a:ea typeface="Cambria" pitchFamily="34" charset="-122"/>
-                <a:cs typeface="Cambria" pitchFamily="34" charset="-120"/>
-              </a:rPr>
-              <a:t>Estratégia básica</a:t>
-            </a:r>
-            <a:endParaRPr lang="en-US" sz="1600" dirty="0"/>
-          </a:p>
-        </p:txBody>
-      </p:sp>
-      <p:sp>
-        <p:nvSpPr>
-          <p:cNvPr id="7" name="Text 2"/>
-          <p:cNvSpPr txBox="1"/>
-          <p:nvPr/>
-        </p:nvSpPr>
-        <p:spPr>
-          <a:xfrm>
-            <a:off x="6263640" y="4892040"/>
-            <a:ext cx="5486400" cy="365760"/>
-          </a:xfrm>
-          <a:prstGeom prst="rect">
-            <a:avLst/>
-          </a:prstGeom>
-          <a:noFill/>
-          <a:ln/>
-        </p:spPr>
-        <p:txBody>
-          <a:bodyPr wrap="square" lIns="0" tIns="0" rIns="0" bIns="0" rtlCol="0" anchor="ctr"/>
-          <a:lstStyle/>
-          <a:p>
-            <a:pPr algn="ctr" indent="0" marL="0">
+            <a:pPr indent="0" marL="0">
               <a:buNone/>
             </a:pPr>
             <a:r>
@@ -6759,7 +6974,7 @@
                 <a:ea typeface="Cambria" pitchFamily="34" charset="-122"/>
                 <a:cs typeface="Cambria" pitchFamily="34" charset="-120"/>
               </a:rPr>
-              <a:t>Simples ≥20 (professor)</a:t>
+              <a:t>O que muda, em números</a:t>
             </a:r>
             <a:endParaRPr lang="en-US" sz="1600" dirty="0"/>
           </a:p>
@@ -6767,14 +6982,14 @@
       </p:sp>
       <p:sp>
         <p:nvSpPr>
-          <p:cNvPr id="8" name="Text 3"/>
+          <p:cNvPr id="7" name="Text 3"/>
           <p:cNvSpPr txBox="1"/>
           <p:nvPr/>
         </p:nvSpPr>
         <p:spPr>
           <a:xfrm>
-            <a:off x="548640" y="5349240"/>
-            <a:ext cx="11064240" cy="822960"/>
+            <a:off x="7315200" y="2011680"/>
+            <a:ext cx="4114800" cy="3977640"/>
           </a:xfrm>
           <a:prstGeom prst="rect">
             <a:avLst/>
@@ -6790,7 +7005,7 @@
               <a:buNone/>
             </a:pPr>
             <a:r>
-              <a:rPr lang="en-US" sz="1400" dirty="0">
+              <a:rPr lang="en-US" sz="1600" dirty="0">
                 <a:solidFill>
                   <a:schemeClr val="tx1"/>
                 </a:solidFill>
@@ -6798,9 +7013,36 @@
                 <a:ea typeface="Calibri" pitchFamily="34" charset="-122"/>
                 <a:cs typeface="Calibri" pitchFamily="34" charset="-120"/>
               </a:rPr>
-              <a:t>Somas altas (≥19) concentram o valor positivo; com soma 12–16 contra dealer forte (10 ou ás) o valor é o pior. A política ≥20 não aproveita somas 17–19, que valem bastante.</a:t>
+              <a:t>20% dos 100 estados (soma 12–21) têm decisão diferente entre as duas políticas.</a:t>
             </a:r>
-            <a:endParaRPr lang="en-US" sz="1400" dirty="0"/>
+            <a:endParaRPr lang="en-US" sz="1600" dirty="0"/>
+          </a:p>
+          <a:p>
+            <a:pPr/>
+            <a:r>
+              <a:rPr sz="1600">
+                <a:latin typeface="Calibri"/>
+              </a:rPr>
+              <a:t>Toda a diferença está concentrada em soma 12–16 contra dealer fraco (2–5).</a:t>
+            </a:r>
+          </a:p>
+          <a:p>
+            <a:pPr/>
+            <a:r>
+              <a:rPr sz="1600">
+                <a:latin typeface="Calibri"/>
+              </a:rPr>
+              <a:t>Ganho real: +0,014 de retorno médio por partida ao reagir à carta do dealer.</a:t>
+            </a:r>
+          </a:p>
+          <a:p>
+            <a:pPr/>
+            <a:r>
+              <a:rPr sz="1600">
+                <a:latin typeface="Calibri"/>
+              </a:rPr>
+              <a:t>Nenhuma das duas políticas usa o ás usável — a decisão é idêntica com ou sem ele.</a:t>
+            </a:r>
           </a:p>
         </p:txBody>
       </p:sp>
@@ -6860,7 +7102,7 @@
 </p:sld>
 </file>
 
-<file path=ppt/slides/slide13.xml><?xml version="1.0" encoding="utf-8"?>
+<file path=ppt/slides/slide14.xml><?xml version="1.0" encoding="utf-8"?>
 <p:sld xmlns:a="http://schemas.openxmlformats.org/drawingml/2006/main" xmlns:r="http://schemas.openxmlformats.org/officeDocument/2006/relationships" xmlns:p="http://schemas.openxmlformats.org/presentationml/2006/main">
   <p:cSld name="Slide 13">
     <p:spTree>
@@ -7140,7 +7382,7 @@
 </p:sld>
 </file>
 
-<file path=ppt/slides/slide14.xml><?xml version="1.0" encoding="utf-8"?>
+<file path=ppt/slides/slide15.xml><?xml version="1.0" encoding="utf-8"?>
 <p:sld xmlns:a="http://schemas.openxmlformats.org/drawingml/2006/main" xmlns:r="http://schemas.openxmlformats.org/officeDocument/2006/relationships" xmlns:p="http://schemas.openxmlformats.org/presentationml/2006/main">
   <p:cSld name="Slide 14">
     <p:spTree>
@@ -7245,7 +7487,7 @@
 </p:sld>
 </file>
 
-<file path=ppt/slides/slide15.xml><?xml version="1.0" encoding="utf-8"?>
+<file path=ppt/slides/slide16.xml><?xml version="1.0" encoding="utf-8"?>
 <p:sld xmlns:a="http://schemas.openxmlformats.org/drawingml/2006/main" xmlns:r="http://schemas.openxmlformats.org/officeDocument/2006/relationships" xmlns:p="http://schemas.openxmlformats.org/presentationml/2006/main">
   <p:cSld name="Slide 15">
     <p:spTree>
@@ -7555,7 +7797,7 @@
 </p:sld>
 </file>
 
-<file path=ppt/slides/slide16.xml><?xml version="1.0" encoding="utf-8"?>
+<file path=ppt/slides/slide17.xml><?xml version="1.0" encoding="utf-8"?>
 <p:sld xmlns:a="http://schemas.openxmlformats.org/drawingml/2006/main" xmlns:r="http://schemas.openxmlformats.org/officeDocument/2006/relationships" xmlns:p="http://schemas.openxmlformats.org/presentationml/2006/main">
   <p:cSld name="Slide 16">
     <p:spTree>
@@ -8409,7 +8651,7 @@
 </p:sld>
 </file>
 
-<file path=ppt/slides/slide17.xml><?xml version="1.0" encoding="utf-8"?>
+<file path=ppt/slides/slide18.xml><?xml version="1.0" encoding="utf-8"?>
 <p:sld xmlns:a="http://schemas.openxmlformats.org/drawingml/2006/main" xmlns:r="http://schemas.openxmlformats.org/officeDocument/2006/relationships" xmlns:p="http://schemas.openxmlformats.org/presentationml/2006/main">
   <p:cSld name="Slide 17">
     <p:spTree>
@@ -9949,7 +10191,7 @@
 </p:sld>
 </file>
 
-<file path=ppt/slides/slide18.xml><?xml version="1.0" encoding="utf-8"?>
+<file path=ppt/slides/slide19.xml><?xml version="1.0" encoding="utf-8"?>
 <p:sld xmlns:a="http://schemas.openxmlformats.org/drawingml/2006/main" xmlns:r="http://schemas.openxmlformats.org/officeDocument/2006/relationships" xmlns:p="http://schemas.openxmlformats.org/presentationml/2006/main">
   <p:cSld name="Slide 18">
     <p:spTree>
@@ -10298,7 +10540,436 @@
 </p:sld>
 </file>
 
-<file path=ppt/slides/slide19.xml><?xml version="1.0" encoding="utf-8"?>
+<file path=ppt/slides/slide2.xml><?xml version="1.0" encoding="utf-8"?>
+<p:sld xmlns:a="http://schemas.openxmlformats.org/drawingml/2006/main" xmlns:r="http://schemas.openxmlformats.org/officeDocument/2006/relationships" xmlns:p="http://schemas.openxmlformats.org/presentationml/2006/main">
+  <p:cSld name="Slide 2">
+    <p:spTree>
+      <p:nvGrpSpPr>
+        <p:cNvPr id="1" name=""/>
+        <p:cNvGrpSpPr/>
+        <p:nvPr/>
+      </p:nvGrpSpPr>
+      <p:grpSpPr>
+        <a:xfrm>
+          <a:off x="0" y="0"/>
+          <a:ext cx="0" cy="0"/>
+          <a:chOff x="0" y="0"/>
+          <a:chExt cx="0" cy="0"/>
+        </a:xfrm>
+      </p:grpSpPr>
+      <p:sp>
+        <p:nvSpPr>
+          <p:cNvPr id="2" name="Text 1"/>
+          <p:cNvSpPr/>
+          <p:nvPr>
+            <p:ph idx="101" type="title" hasCustomPrompt="1"/>
+          </p:nvPr>
+        </p:nvSpPr>
+        <p:spPr>
+          <a:xfrm>
+            <a:off x="548640" y="320040"/>
+            <a:ext cx="11064240" cy="822960"/>
+          </a:xfrm>
+          <a:prstGeom prst="rect">
+            <a:avLst/>
+          </a:prstGeom>
+          <a:noFill/>
+          <a:ln/>
+        </p:spPr>
+        <p:txBody>
+          <a:bodyPr wrap="square" lIns="0" tIns="0" rIns="0" bIns="0" rtlCol="0" anchor="ctr"/>
+          <a:lstStyle/>
+          <a:p>
+            <a:pPr indent="0" marL="0">
+              <a:buNone/>
+            </a:pPr>
+            <a:r>
+              <a:rPr lang="en-US" sz="3200" b="1" dirty="0">
+                <a:solidFill>
+                  <a:schemeClr val="tx2"/>
+                </a:solidFill>
+                <a:latin typeface="Cambria" pitchFamily="34" charset="0"/>
+                <a:ea typeface="Cambria" pitchFamily="34" charset="-122"/>
+                <a:cs typeface="Cambria" pitchFamily="34" charset="-120"/>
+              </a:rPr>
+              <a:t>A pergunta: dá para aprender a jogar só jogando?</a:t>
+            </a:r>
+            <a:endParaRPr lang="en-US" sz="3200" dirty="0"/>
+          </a:p>
+        </p:txBody>
+      </p:sp>
+      <p:sp>
+        <p:nvSpPr>
+          <p:cNvPr id="4" name="card 1 · Implementação"/>
+          <p:cNvSpPr/>
+          <p:nvPr/>
+        </p:nvSpPr>
+        <p:spPr>
+          <a:xfrm>
+            <a:off x="548640" y="1463040"/>
+            <a:ext cx="3566160" cy="3291840"/>
+          </a:xfrm>
+          <a:prstGeom prst="roundRect">
+            <a:avLst>
+              <a:gd name="adj" fmla="val 2222"/>
+            </a:avLst>
+          </a:prstGeom>
+          <a:solidFill>
+            <a:schemeClr val="bg2"/>
+          </a:solidFill>
+          <a:ln w="12700">
+            <a:solidFill>
+              <a:schemeClr val="bg2"/>
+            </a:solidFill>
+            <a:prstDash val="solid"/>
+          </a:ln>
+        </p:spPr>
+      </p:sp>
+      <p:sp>
+        <p:nvSpPr>
+          <p:cNvPr id="5" name="Text 2"/>
+          <p:cNvSpPr txBox="1"/>
+          <p:nvPr/>
+        </p:nvSpPr>
+        <p:spPr>
+          <a:xfrm>
+            <a:off x="731520" y="1600200"/>
+            <a:ext cx="3200400" cy="365760"/>
+          </a:xfrm>
+          <a:prstGeom prst="rect">
+            <a:avLst/>
+          </a:prstGeom>
+          <a:noFill/>
+          <a:ln/>
+        </p:spPr>
+        <p:txBody>
+          <a:bodyPr wrap="square" lIns="0" tIns="0" rIns="0" bIns="0" rtlCol="0" anchor="ctr"/>
+          <a:lstStyle/>
+          <a:p>
+            <a:pPr indent="0" marL="0">
+              <a:buNone/>
+            </a:pPr>
+            <a:r>
+              <a:rPr lang="en-US" sz="1600" b="1" dirty="0">
+                <a:solidFill>
+                  <a:srgbClr val="0B6E4F"/>
+                </a:solidFill>
+                <a:latin typeface="Cambria" pitchFamily="34" charset="0"/>
+                <a:ea typeface="Cambria" pitchFamily="34" charset="-122"/>
+                <a:cs typeface="Cambria" pitchFamily="34" charset="-120"/>
+              </a:rPr>
+              <a:t>1 · Implementação</a:t>
+            </a:r>
+            <a:endParaRPr lang="en-US" sz="1600" dirty="0"/>
+          </a:p>
+        </p:txBody>
+      </p:sp>
+      <p:sp>
+        <p:nvSpPr>
+          <p:cNvPr id="6" name="Text 3"/>
+          <p:cNvSpPr txBox="1"/>
+          <p:nvPr/>
+        </p:nvSpPr>
+        <p:spPr>
+          <a:xfrm>
+            <a:off x="731520" y="2011680"/>
+            <a:ext cx="3200400" cy="2651760"/>
+          </a:xfrm>
+          <a:prstGeom prst="rect">
+            <a:avLst/>
+          </a:prstGeom>
+          <a:noFill/>
+          <a:ln/>
+        </p:spPr>
+        <p:txBody>
+          <a:bodyPr wrap="square" lIns="0" tIns="0" rIns="0" bIns="0" rtlCol="0" anchor="t"/>
+          <a:lstStyle/>
+          <a:p>
+            <a:pPr indent="0" marL="0">
+              <a:buNone/>
+            </a:pPr>
+            <a:r>
+              <a:rPr lang="en-US" sz="1800" dirty="0">
+                <a:solidFill>
+                  <a:schemeClr val="tx1"/>
+                </a:solidFill>
+                <a:latin typeface="Calibri" pitchFamily="34" charset="0"/>
+                <a:ea typeface="Calibri" pitchFamily="34" charset="-122"/>
+                <a:cs typeface="Calibri" pitchFamily="34" charset="-120"/>
+              </a:rPr>
+              <a:t>Leitura crítica do notebook do professor: First-Visit, Exploring Starts e On-Policy ε-greedy, comparados com a teoria (Sutton &amp; Barto, cap. 5) e com correções documentadas.</a:t>
+            </a:r>
+            <a:endParaRPr lang="en-US" sz="1800" dirty="0"/>
+          </a:p>
+        </p:txBody>
+      </p:sp>
+      <p:sp>
+        <p:nvSpPr>
+          <p:cNvPr id="7" name="card 2 · Políticas próprias"/>
+          <p:cNvSpPr/>
+          <p:nvPr/>
+        </p:nvSpPr>
+        <p:spPr>
+          <a:xfrm>
+            <a:off x="4297680" y="1463040"/>
+            <a:ext cx="3566160" cy="3291840"/>
+          </a:xfrm>
+          <a:prstGeom prst="roundRect">
+            <a:avLst>
+              <a:gd name="adj" fmla="val 2222"/>
+            </a:avLst>
+          </a:prstGeom>
+          <a:solidFill>
+            <a:schemeClr val="bg2"/>
+          </a:solidFill>
+          <a:ln w="12700">
+            <a:solidFill>
+              <a:schemeClr val="bg2"/>
+            </a:solidFill>
+            <a:prstDash val="solid"/>
+          </a:ln>
+        </p:spPr>
+      </p:sp>
+      <p:sp>
+        <p:nvSpPr>
+          <p:cNvPr id="8" name="Text 5"/>
+          <p:cNvSpPr txBox="1"/>
+          <p:nvPr/>
+        </p:nvSpPr>
+        <p:spPr>
+          <a:xfrm>
+            <a:off x="4480560" y="1600200"/>
+            <a:ext cx="3200400" cy="365760"/>
+          </a:xfrm>
+          <a:prstGeom prst="rect">
+            <a:avLst/>
+          </a:prstGeom>
+          <a:noFill/>
+          <a:ln/>
+        </p:spPr>
+        <p:txBody>
+          <a:bodyPr wrap="square" lIns="0" tIns="0" rIns="0" bIns="0" rtlCol="0" anchor="ctr"/>
+          <a:lstStyle/>
+          <a:p>
+            <a:pPr indent="0" marL="0">
+              <a:buNone/>
+            </a:pPr>
+            <a:r>
+              <a:rPr lang="en-US" sz="1600" b="1" dirty="0">
+                <a:solidFill>
+                  <a:srgbClr val="C9A227"/>
+                </a:solidFill>
+                <a:latin typeface="Cambria" pitchFamily="34" charset="0"/>
+                <a:ea typeface="Cambria" pitchFamily="34" charset="-122"/>
+                <a:cs typeface="Cambria" pitchFamily="34" charset="-120"/>
+              </a:rPr>
+              <a:t>2 · Políticas próprias</a:t>
+            </a:r>
+            <a:endParaRPr lang="en-US" sz="1600" dirty="0"/>
+          </a:p>
+        </p:txBody>
+      </p:sp>
+      <p:sp>
+        <p:nvSpPr>
+          <p:cNvPr id="9" name="Text 6"/>
+          <p:cNvSpPr txBox="1"/>
+          <p:nvPr/>
+        </p:nvSpPr>
+        <p:spPr>
+          <a:xfrm>
+            <a:off x="4480560" y="2011680"/>
+            <a:ext cx="3200400" cy="2651760"/>
+          </a:xfrm>
+          <a:prstGeom prst="rect">
+            <a:avLst/>
+          </a:prstGeom>
+          <a:noFill/>
+          <a:ln/>
+        </p:spPr>
+        <p:txBody>
+          <a:bodyPr wrap="square" lIns="0" tIns="0" rIns="0" bIns="0" rtlCol="0" anchor="t"/>
+          <a:lstStyle/>
+          <a:p>
+            <a:pPr indent="0" marL="0">
+              <a:buNone/>
+            </a:pPr>
+            <a:r>
+              <a:rPr lang="en-US" sz="1800" dirty="0">
+                <a:solidFill>
+                  <a:schemeClr val="tx1"/>
+                </a:solidFill>
+                <a:latin typeface="Calibri" pitchFamily="34" charset="0"/>
+                <a:ea typeface="Calibri" pitchFamily="34" charset="-122"/>
+                <a:cs typeface="Calibri" pitchFamily="34" charset="-120"/>
+              </a:rPr>
+              <a:t>Quatro políticas avaliadas com First-Visit MC no Blackjack-v1: retorno médio, taxa de vitória e mapas de V(s) sobre os 280 estados.</a:t>
+            </a:r>
+            <a:endParaRPr lang="en-US" sz="1800" dirty="0"/>
+          </a:p>
+        </p:txBody>
+      </p:sp>
+      <p:sp>
+        <p:nvSpPr>
+          <p:cNvPr id="10" name="card 3 · Experimentos"/>
+          <p:cNvSpPr/>
+          <p:nvPr/>
+        </p:nvSpPr>
+        <p:spPr>
+          <a:xfrm>
+            <a:off x="8046720" y="1463040"/>
+            <a:ext cx="3566160" cy="3291840"/>
+          </a:xfrm>
+          <a:prstGeom prst="roundRect">
+            <a:avLst>
+              <a:gd name="adj" fmla="val 2222"/>
+            </a:avLst>
+          </a:prstGeom>
+          <a:solidFill>
+            <a:schemeClr val="bg2"/>
+          </a:solidFill>
+          <a:ln w="12700">
+            <a:solidFill>
+              <a:schemeClr val="bg2"/>
+            </a:solidFill>
+            <a:prstDash val="solid"/>
+          </a:ln>
+        </p:spPr>
+      </p:sp>
+      <p:sp>
+        <p:nvSpPr>
+          <p:cNvPr id="11" name="Text 8"/>
+          <p:cNvSpPr txBox="1"/>
+          <p:nvPr/>
+        </p:nvSpPr>
+        <p:spPr>
+          <a:xfrm>
+            <a:off x="8229600" y="1600200"/>
+            <a:ext cx="3200400" cy="365760"/>
+          </a:xfrm>
+          <a:prstGeom prst="rect">
+            <a:avLst/>
+          </a:prstGeom>
+          <a:noFill/>
+          <a:ln/>
+        </p:spPr>
+        <p:txBody>
+          <a:bodyPr wrap="square" lIns="0" tIns="0" rIns="0" bIns="0" rtlCol="0" anchor="ctr"/>
+          <a:lstStyle/>
+          <a:p>
+            <a:pPr indent="0" marL="0">
+              <a:buNone/>
+            </a:pPr>
+            <a:r>
+              <a:rPr lang="en-US" sz="1600" b="1" dirty="0">
+                <a:solidFill>
+                  <a:srgbClr val="3A6EA5"/>
+                </a:solidFill>
+                <a:latin typeface="Cambria" pitchFamily="34" charset="0"/>
+                <a:ea typeface="Cambria" pitchFamily="34" charset="-122"/>
+                <a:cs typeface="Cambria" pitchFamily="34" charset="-120"/>
+              </a:rPr>
+              <a:t>3 · Experimentos</a:t>
+            </a:r>
+            <a:endParaRPr lang="en-US" sz="1600" dirty="0"/>
+          </a:p>
+        </p:txBody>
+      </p:sp>
+      <p:sp>
+        <p:nvSpPr>
+          <p:cNvPr id="12" name="Text 9"/>
+          <p:cNvSpPr txBox="1"/>
+          <p:nvPr/>
+        </p:nvSpPr>
+        <p:spPr>
+          <a:xfrm>
+            <a:off x="8229600" y="2011680"/>
+            <a:ext cx="3200400" cy="2651760"/>
+          </a:xfrm>
+          <a:prstGeom prst="rect">
+            <a:avLst/>
+          </a:prstGeom>
+          <a:noFill/>
+          <a:ln/>
+        </p:spPr>
+        <p:txBody>
+          <a:bodyPr wrap="square" lIns="0" tIns="0" rIns="0" bIns="0" rtlCol="0" anchor="t"/>
+          <a:lstStyle/>
+          <a:p>
+            <a:pPr indent="0" marL="0">
+              <a:buNone/>
+            </a:pPr>
+            <a:r>
+              <a:rPr lang="en-US" sz="1800" dirty="0">
+                <a:solidFill>
+                  <a:schemeClr val="tx1"/>
+                </a:solidFill>
+                <a:latin typeface="Calibri" pitchFamily="34" charset="0"/>
+                <a:ea typeface="Calibri" pitchFamily="34" charset="-122"/>
+                <a:cs typeface="Calibri" pitchFamily="34" charset="-120"/>
+              </a:rPr>
+              <a:t>ES × On-Policy variando ε, decaimento de ε e γ; 3 seeds por configuração e até 200.000 episódios de treino.</a:t>
+            </a:r>
+            <a:endParaRPr lang="en-US" sz="1800" dirty="0"/>
+          </a:p>
+        </p:txBody>
+      </p:sp>
+      <p:sp>
+        <p:nvSpPr>
+          <p:cNvPr id="25" name="Slide Number Placeholder 0"/>
+          <p:cNvSpPr>
+            <a:spLocks noGrp="1"/>
+          </p:cNvSpPr>
+          <p:nvPr>
+            <p:ph type="sldNum" sz="quarter" idx="4294967295"/>
+          </p:nvPr>
+        </p:nvSpPr>
+        <p:spPr>
+          <a:xfrm>
+            <a:off x="11247120" y="6446520"/>
+            <a:ext cx="548640" cy="274320"/>
+          </a:xfrm>
+          <a:prstGeom prst="rect">
+            <a:avLst/>
+          </a:prstGeom>
+          <a:extLst>
+            <a:ext uri="{C572A759-6A51-4108-AA02-DFA0A04FC94B}">
+              <ma14:wrappingTextBoxFlag xmlns:ma14="http://schemas.microsoft.com/office/mac/drawingml/2011/main" val="0"/>
+            </a:ext>
+          </a:extLst>
+        </p:spPr>
+        <p:txBody>
+          <a:bodyPr/>
+          <a:lstStyle>
+            <a:lvl1pPr>
+              <a:defRPr sz="1000">
+                <a:solidFill>
+                  <a:schemeClr val="tx2"/>
+                </a:solidFill>
+                <a:latin typeface="Calibri"/>
+                <a:ea typeface="Calibri"/>
+                <a:cs typeface="Calibri"/>
+              </a:defRPr>
+            </a:lvl1pPr>
+          </a:lstStyle>
+          <a:p>
+            <a:pPr algn="r"/>
+            <a:fld id="{F7021451-1387-4CA6-816F-3879F97B5CBC}" type="slidenum">
+              <a:rPr b="0" lang="en-US"/>
+              <a:t>2</a:t>
+            </a:fld>
+            <a:endParaRPr lang="en-US"/>
+          </a:p>
+        </p:txBody>
+      </p:sp>
+    </p:spTree>
+  </p:cSld>
+  <p:clrMapOvr>
+    <a:masterClrMapping/>
+  </p:clrMapOvr>
+</p:sld>
+</file>
+
+<file path=ppt/slides/slide20.xml><?xml version="1.0" encoding="utf-8"?>
 <p:sld xmlns:a="http://schemas.openxmlformats.org/drawingml/2006/main" xmlns:r="http://schemas.openxmlformats.org/officeDocument/2006/relationships" xmlns:p="http://schemas.openxmlformats.org/presentationml/2006/main">
   <p:cSld name="Slide 19">
     <p:spTree>
@@ -10483,436 +11154,7 @@
 </p:sld>
 </file>
 
-<file path=ppt/slides/slide2.xml><?xml version="1.0" encoding="utf-8"?>
-<p:sld xmlns:a="http://schemas.openxmlformats.org/drawingml/2006/main" xmlns:r="http://schemas.openxmlformats.org/officeDocument/2006/relationships" xmlns:p="http://schemas.openxmlformats.org/presentationml/2006/main">
-  <p:cSld name="Slide 2">
-    <p:spTree>
-      <p:nvGrpSpPr>
-        <p:cNvPr id="1" name=""/>
-        <p:cNvGrpSpPr/>
-        <p:nvPr/>
-      </p:nvGrpSpPr>
-      <p:grpSpPr>
-        <a:xfrm>
-          <a:off x="0" y="0"/>
-          <a:ext cx="0" cy="0"/>
-          <a:chOff x="0" y="0"/>
-          <a:chExt cx="0" cy="0"/>
-        </a:xfrm>
-      </p:grpSpPr>
-      <p:sp>
-        <p:nvSpPr>
-          <p:cNvPr id="2" name="Text 1"/>
-          <p:cNvSpPr/>
-          <p:nvPr>
-            <p:ph idx="101" type="title" hasCustomPrompt="1"/>
-          </p:nvPr>
-        </p:nvSpPr>
-        <p:spPr>
-          <a:xfrm>
-            <a:off x="548640" y="320040"/>
-            <a:ext cx="11064240" cy="822960"/>
-          </a:xfrm>
-          <a:prstGeom prst="rect">
-            <a:avLst/>
-          </a:prstGeom>
-          <a:noFill/>
-          <a:ln/>
-        </p:spPr>
-        <p:txBody>
-          <a:bodyPr wrap="square" lIns="0" tIns="0" rIns="0" bIns="0" rtlCol="0" anchor="ctr"/>
-          <a:lstStyle/>
-          <a:p>
-            <a:pPr indent="0" marL="0">
-              <a:buNone/>
-            </a:pPr>
-            <a:r>
-              <a:rPr lang="en-US" sz="3200" b="1" dirty="0">
-                <a:solidFill>
-                  <a:schemeClr val="tx2"/>
-                </a:solidFill>
-                <a:latin typeface="Cambria" pitchFamily="34" charset="0"/>
-                <a:ea typeface="Cambria" pitchFamily="34" charset="-122"/>
-                <a:cs typeface="Cambria" pitchFamily="34" charset="-120"/>
-              </a:rPr>
-              <a:t>A pergunta: dá para aprender a jogar só jogando?</a:t>
-            </a:r>
-            <a:endParaRPr lang="en-US" sz="3200" dirty="0"/>
-          </a:p>
-        </p:txBody>
-      </p:sp>
-      <p:sp>
-        <p:nvSpPr>
-          <p:cNvPr id="4" name="card 1 · Implementação"/>
-          <p:cNvSpPr/>
-          <p:nvPr/>
-        </p:nvSpPr>
-        <p:spPr>
-          <a:xfrm>
-            <a:off x="548640" y="1463040"/>
-            <a:ext cx="3566160" cy="3291840"/>
-          </a:xfrm>
-          <a:prstGeom prst="roundRect">
-            <a:avLst>
-              <a:gd name="adj" fmla="val 2222"/>
-            </a:avLst>
-          </a:prstGeom>
-          <a:solidFill>
-            <a:schemeClr val="bg2"/>
-          </a:solidFill>
-          <a:ln w="12700">
-            <a:solidFill>
-              <a:schemeClr val="bg2"/>
-            </a:solidFill>
-            <a:prstDash val="solid"/>
-          </a:ln>
-        </p:spPr>
-      </p:sp>
-      <p:sp>
-        <p:nvSpPr>
-          <p:cNvPr id="5" name="Text 2"/>
-          <p:cNvSpPr txBox="1"/>
-          <p:nvPr/>
-        </p:nvSpPr>
-        <p:spPr>
-          <a:xfrm>
-            <a:off x="731520" y="1600200"/>
-            <a:ext cx="3200400" cy="365760"/>
-          </a:xfrm>
-          <a:prstGeom prst="rect">
-            <a:avLst/>
-          </a:prstGeom>
-          <a:noFill/>
-          <a:ln/>
-        </p:spPr>
-        <p:txBody>
-          <a:bodyPr wrap="square" lIns="0" tIns="0" rIns="0" bIns="0" rtlCol="0" anchor="ctr"/>
-          <a:lstStyle/>
-          <a:p>
-            <a:pPr indent="0" marL="0">
-              <a:buNone/>
-            </a:pPr>
-            <a:r>
-              <a:rPr lang="en-US" sz="1600" b="1" dirty="0">
-                <a:solidFill>
-                  <a:srgbClr val="0B6E4F"/>
-                </a:solidFill>
-                <a:latin typeface="Cambria" pitchFamily="34" charset="0"/>
-                <a:ea typeface="Cambria" pitchFamily="34" charset="-122"/>
-                <a:cs typeface="Cambria" pitchFamily="34" charset="-120"/>
-              </a:rPr>
-              <a:t>1 · Implementação</a:t>
-            </a:r>
-            <a:endParaRPr lang="en-US" sz="1600" dirty="0"/>
-          </a:p>
-        </p:txBody>
-      </p:sp>
-      <p:sp>
-        <p:nvSpPr>
-          <p:cNvPr id="6" name="Text 3"/>
-          <p:cNvSpPr txBox="1"/>
-          <p:nvPr/>
-        </p:nvSpPr>
-        <p:spPr>
-          <a:xfrm>
-            <a:off x="731520" y="2011680"/>
-            <a:ext cx="3200400" cy="2651760"/>
-          </a:xfrm>
-          <a:prstGeom prst="rect">
-            <a:avLst/>
-          </a:prstGeom>
-          <a:noFill/>
-          <a:ln/>
-        </p:spPr>
-        <p:txBody>
-          <a:bodyPr wrap="square" lIns="0" tIns="0" rIns="0" bIns="0" rtlCol="0" anchor="t"/>
-          <a:lstStyle/>
-          <a:p>
-            <a:pPr indent="0" marL="0">
-              <a:buNone/>
-            </a:pPr>
-            <a:r>
-              <a:rPr lang="en-US" sz="1800" dirty="0">
-                <a:solidFill>
-                  <a:schemeClr val="tx1"/>
-                </a:solidFill>
-                <a:latin typeface="Calibri" pitchFamily="34" charset="0"/>
-                <a:ea typeface="Calibri" pitchFamily="34" charset="-122"/>
-                <a:cs typeface="Calibri" pitchFamily="34" charset="-120"/>
-              </a:rPr>
-              <a:t>Leitura crítica do notebook do professor: First-Visit, Exploring Starts e On-Policy ε-greedy, comparados com a teoria (Sutton &amp; Barto, cap. 5) e com correções documentadas.</a:t>
-            </a:r>
-            <a:endParaRPr lang="en-US" sz="1800" dirty="0"/>
-          </a:p>
-        </p:txBody>
-      </p:sp>
-      <p:sp>
-        <p:nvSpPr>
-          <p:cNvPr id="7" name="card 2 · Políticas próprias"/>
-          <p:cNvSpPr/>
-          <p:nvPr/>
-        </p:nvSpPr>
-        <p:spPr>
-          <a:xfrm>
-            <a:off x="4297680" y="1463040"/>
-            <a:ext cx="3566160" cy="3291840"/>
-          </a:xfrm>
-          <a:prstGeom prst="roundRect">
-            <a:avLst>
-              <a:gd name="adj" fmla="val 2222"/>
-            </a:avLst>
-          </a:prstGeom>
-          <a:solidFill>
-            <a:schemeClr val="bg2"/>
-          </a:solidFill>
-          <a:ln w="12700">
-            <a:solidFill>
-              <a:schemeClr val="bg2"/>
-            </a:solidFill>
-            <a:prstDash val="solid"/>
-          </a:ln>
-        </p:spPr>
-      </p:sp>
-      <p:sp>
-        <p:nvSpPr>
-          <p:cNvPr id="8" name="Text 5"/>
-          <p:cNvSpPr txBox="1"/>
-          <p:nvPr/>
-        </p:nvSpPr>
-        <p:spPr>
-          <a:xfrm>
-            <a:off x="4480560" y="1600200"/>
-            <a:ext cx="3200400" cy="365760"/>
-          </a:xfrm>
-          <a:prstGeom prst="rect">
-            <a:avLst/>
-          </a:prstGeom>
-          <a:noFill/>
-          <a:ln/>
-        </p:spPr>
-        <p:txBody>
-          <a:bodyPr wrap="square" lIns="0" tIns="0" rIns="0" bIns="0" rtlCol="0" anchor="ctr"/>
-          <a:lstStyle/>
-          <a:p>
-            <a:pPr indent="0" marL="0">
-              <a:buNone/>
-            </a:pPr>
-            <a:r>
-              <a:rPr lang="en-US" sz="1600" b="1" dirty="0">
-                <a:solidFill>
-                  <a:srgbClr val="C9A227"/>
-                </a:solidFill>
-                <a:latin typeface="Cambria" pitchFamily="34" charset="0"/>
-                <a:ea typeface="Cambria" pitchFamily="34" charset="-122"/>
-                <a:cs typeface="Cambria" pitchFamily="34" charset="-120"/>
-              </a:rPr>
-              <a:t>2 · Políticas próprias</a:t>
-            </a:r>
-            <a:endParaRPr lang="en-US" sz="1600" dirty="0"/>
-          </a:p>
-        </p:txBody>
-      </p:sp>
-      <p:sp>
-        <p:nvSpPr>
-          <p:cNvPr id="9" name="Text 6"/>
-          <p:cNvSpPr txBox="1"/>
-          <p:nvPr/>
-        </p:nvSpPr>
-        <p:spPr>
-          <a:xfrm>
-            <a:off x="4480560" y="2011680"/>
-            <a:ext cx="3200400" cy="2651760"/>
-          </a:xfrm>
-          <a:prstGeom prst="rect">
-            <a:avLst/>
-          </a:prstGeom>
-          <a:noFill/>
-          <a:ln/>
-        </p:spPr>
-        <p:txBody>
-          <a:bodyPr wrap="square" lIns="0" tIns="0" rIns="0" bIns="0" rtlCol="0" anchor="t"/>
-          <a:lstStyle/>
-          <a:p>
-            <a:pPr indent="0" marL="0">
-              <a:buNone/>
-            </a:pPr>
-            <a:r>
-              <a:rPr lang="en-US" sz="1800" dirty="0">
-                <a:solidFill>
-                  <a:schemeClr val="tx1"/>
-                </a:solidFill>
-                <a:latin typeface="Calibri" pitchFamily="34" charset="0"/>
-                <a:ea typeface="Calibri" pitchFamily="34" charset="-122"/>
-                <a:cs typeface="Calibri" pitchFamily="34" charset="-120"/>
-              </a:rPr>
-              <a:t>Quatro políticas avaliadas com First-Visit MC no Blackjack-v1: retorno médio, taxa de vitória e mapas de V(s) sobre os 280 estados.</a:t>
-            </a:r>
-            <a:endParaRPr lang="en-US" sz="1800" dirty="0"/>
-          </a:p>
-        </p:txBody>
-      </p:sp>
-      <p:sp>
-        <p:nvSpPr>
-          <p:cNvPr id="10" name="card 3 · Experimentos"/>
-          <p:cNvSpPr/>
-          <p:nvPr/>
-        </p:nvSpPr>
-        <p:spPr>
-          <a:xfrm>
-            <a:off x="8046720" y="1463040"/>
-            <a:ext cx="3566160" cy="3291840"/>
-          </a:xfrm>
-          <a:prstGeom prst="roundRect">
-            <a:avLst>
-              <a:gd name="adj" fmla="val 2222"/>
-            </a:avLst>
-          </a:prstGeom>
-          <a:solidFill>
-            <a:schemeClr val="bg2"/>
-          </a:solidFill>
-          <a:ln w="12700">
-            <a:solidFill>
-              <a:schemeClr val="bg2"/>
-            </a:solidFill>
-            <a:prstDash val="solid"/>
-          </a:ln>
-        </p:spPr>
-      </p:sp>
-      <p:sp>
-        <p:nvSpPr>
-          <p:cNvPr id="11" name="Text 8"/>
-          <p:cNvSpPr txBox="1"/>
-          <p:nvPr/>
-        </p:nvSpPr>
-        <p:spPr>
-          <a:xfrm>
-            <a:off x="8229600" y="1600200"/>
-            <a:ext cx="3200400" cy="365760"/>
-          </a:xfrm>
-          <a:prstGeom prst="rect">
-            <a:avLst/>
-          </a:prstGeom>
-          <a:noFill/>
-          <a:ln/>
-        </p:spPr>
-        <p:txBody>
-          <a:bodyPr wrap="square" lIns="0" tIns="0" rIns="0" bIns="0" rtlCol="0" anchor="ctr"/>
-          <a:lstStyle/>
-          <a:p>
-            <a:pPr indent="0" marL="0">
-              <a:buNone/>
-            </a:pPr>
-            <a:r>
-              <a:rPr lang="en-US" sz="1600" b="1" dirty="0">
-                <a:solidFill>
-                  <a:srgbClr val="3A6EA5"/>
-                </a:solidFill>
-                <a:latin typeface="Cambria" pitchFamily="34" charset="0"/>
-                <a:ea typeface="Cambria" pitchFamily="34" charset="-122"/>
-                <a:cs typeface="Cambria" pitchFamily="34" charset="-120"/>
-              </a:rPr>
-              <a:t>3 · Experimentos</a:t>
-            </a:r>
-            <a:endParaRPr lang="en-US" sz="1600" dirty="0"/>
-          </a:p>
-        </p:txBody>
-      </p:sp>
-      <p:sp>
-        <p:nvSpPr>
-          <p:cNvPr id="12" name="Text 9"/>
-          <p:cNvSpPr txBox="1"/>
-          <p:nvPr/>
-        </p:nvSpPr>
-        <p:spPr>
-          <a:xfrm>
-            <a:off x="8229600" y="2011680"/>
-            <a:ext cx="3200400" cy="2651760"/>
-          </a:xfrm>
-          <a:prstGeom prst="rect">
-            <a:avLst/>
-          </a:prstGeom>
-          <a:noFill/>
-          <a:ln/>
-        </p:spPr>
-        <p:txBody>
-          <a:bodyPr wrap="square" lIns="0" tIns="0" rIns="0" bIns="0" rtlCol="0" anchor="t"/>
-          <a:lstStyle/>
-          <a:p>
-            <a:pPr indent="0" marL="0">
-              <a:buNone/>
-            </a:pPr>
-            <a:r>
-              <a:rPr lang="en-US" sz="1800" dirty="0">
-                <a:solidFill>
-                  <a:schemeClr val="tx1"/>
-                </a:solidFill>
-                <a:latin typeface="Calibri" pitchFamily="34" charset="0"/>
-                <a:ea typeface="Calibri" pitchFamily="34" charset="-122"/>
-                <a:cs typeface="Calibri" pitchFamily="34" charset="-120"/>
-              </a:rPr>
-              <a:t>ES × On-Policy variando ε, decaimento de ε e γ; 3 seeds por configuração e até 200.000 episódios de treino.</a:t>
-            </a:r>
-            <a:endParaRPr lang="en-US" sz="1800" dirty="0"/>
-          </a:p>
-        </p:txBody>
-      </p:sp>
-      <p:sp>
-        <p:nvSpPr>
-          <p:cNvPr id="25" name="Slide Number Placeholder 0"/>
-          <p:cNvSpPr>
-            <a:spLocks noGrp="1"/>
-          </p:cNvSpPr>
-          <p:nvPr>
-            <p:ph type="sldNum" sz="quarter" idx="4294967295"/>
-          </p:nvPr>
-        </p:nvSpPr>
-        <p:spPr>
-          <a:xfrm>
-            <a:off x="11247120" y="6446520"/>
-            <a:ext cx="548640" cy="274320"/>
-          </a:xfrm>
-          <a:prstGeom prst="rect">
-            <a:avLst/>
-          </a:prstGeom>
-          <a:extLst>
-            <a:ext uri="{C572A759-6A51-4108-AA02-DFA0A04FC94B}">
-              <ma14:wrappingTextBoxFlag xmlns:ma14="http://schemas.microsoft.com/office/mac/drawingml/2011/main" val="0"/>
-            </a:ext>
-          </a:extLst>
-        </p:spPr>
-        <p:txBody>
-          <a:bodyPr/>
-          <a:lstStyle>
-            <a:lvl1pPr>
-              <a:defRPr sz="1000">
-                <a:solidFill>
-                  <a:schemeClr val="tx2"/>
-                </a:solidFill>
-                <a:latin typeface="Calibri"/>
-                <a:ea typeface="Calibri"/>
-                <a:cs typeface="Calibri"/>
-              </a:defRPr>
-            </a:lvl1pPr>
-          </a:lstStyle>
-          <a:p>
-            <a:pPr algn="r"/>
-            <a:fld id="{F7021451-1387-4CA6-816F-3879F97B5CBC}" type="slidenum">
-              <a:rPr b="0" lang="en-US"/>
-              <a:t>2</a:t>
-            </a:fld>
-            <a:endParaRPr lang="en-US"/>
-          </a:p>
-        </p:txBody>
-      </p:sp>
-    </p:spTree>
-  </p:cSld>
-  <p:clrMapOvr>
-    <a:masterClrMapping/>
-  </p:clrMapOvr>
-</p:sld>
-</file>
-
-<file path=ppt/slides/slide20.xml><?xml version="1.0" encoding="utf-8"?>
+<file path=ppt/slides/slide21.xml><?xml version="1.0" encoding="utf-8"?>
 <p:sld xmlns:a="http://schemas.openxmlformats.org/drawingml/2006/main" xmlns:r="http://schemas.openxmlformats.org/officeDocument/2006/relationships" xmlns:p="http://schemas.openxmlformats.org/presentationml/2006/main">
   <p:cSld name="Slide 20">
     <p:spTree>
@@ -11148,7 +11390,7 @@
 </p:sld>
 </file>
 
-<file path=ppt/slides/slide21.xml><?xml version="1.0" encoding="utf-8"?>
+<file path=ppt/slides/slide22.xml><?xml version="1.0" encoding="utf-8"?>
 <p:sld xmlns:a="http://schemas.openxmlformats.org/drawingml/2006/main" xmlns:r="http://schemas.openxmlformats.org/officeDocument/2006/relationships" xmlns:p="http://schemas.openxmlformats.org/presentationml/2006/main">
   <p:cSld name="Slide 21">
     <p:spTree>
@@ -11427,7 +11669,7 @@
 </p:sld>
 </file>
 
-<file path=ppt/slides/slide22.xml><?xml version="1.0" encoding="utf-8"?>
+<file path=ppt/slides/slide23.xml><?xml version="1.0" encoding="utf-8"?>
 <p:sld xmlns:a="http://schemas.openxmlformats.org/drawingml/2006/main" xmlns:r="http://schemas.openxmlformats.org/officeDocument/2006/relationships" xmlns:p="http://schemas.openxmlformats.org/presentationml/2006/main">
   <p:cSld name="Slide 22">
     <p:spTree>
@@ -11961,7 +12203,7 @@
 </p:sld>
 </file>
 
-<file path=ppt/slides/slide23.xml><?xml version="1.0" encoding="utf-8"?>
+<file path=ppt/slides/slide24.xml><?xml version="1.0" encoding="utf-8"?>
 <p:sld xmlns:a="http://schemas.openxmlformats.org/drawingml/2006/main" xmlns:r="http://schemas.openxmlformats.org/officeDocument/2006/relationships" xmlns:p="http://schemas.openxmlformats.org/presentationml/2006/main">
   <p:cSld name="Slide 23">
     <p:spTree>
@@ -12233,7 +12475,7 @@
                 <a:ea typeface="Cambria" pitchFamily="34" charset="-122"/>
                 <a:cs typeface="Cambria" pitchFamily="34" charset="-120"/>
               </a:rPr>
-              <a:t>Sim: o Monte Carlo chega perto da estratégia clássica</a:t>
+              <a:t>Aprender do zero supera nossas políticas manuais</a:t>
             </a:r>
             <a:endParaRPr lang="en-US" sz="3200" dirty="0"/>
           </a:p>
@@ -12272,7 +12514,7 @@
                 <a:ea typeface="Cambria" pitchFamily="34" charset="-122"/>
                 <a:cs typeface="Cambria" pitchFamily="34" charset="-120"/>
               </a:rPr>
-              <a:t>-0,041</a:t>
+              <a:t>-0,059</a:t>
             </a:r>
             <a:endParaRPr lang="en-US" sz="4000" dirty="0"/>
           </a:p>
@@ -12311,7 +12553,7 @@
                 <a:ea typeface="Calibri" pitchFamily="34" charset="-122"/>
                 <a:cs typeface="Calibri" pitchFamily="34" charset="-120"/>
               </a:rPr>
-              <a:t>retorno médio da estratégia básica (a melhor política avaliada)</a:t>
+              <a:t>retorno médio de "Depende da carta do dealer" (a melhor das nossas 2 políticas)</a:t>
             </a:r>
             <a:endParaRPr lang="en-US" sz="1400" dirty="0"/>
           </a:p>
@@ -12552,7 +12794,7 @@
                 <a:ea typeface="Calibri" pitchFamily="34" charset="-122"/>
                 <a:cs typeface="Calibri" pitchFamily="34" charset="-120"/>
               </a:rPr>
-              <a:t>ES e On-Policy chegam a políticas quase idênticas à estratégia básica; só ε = 0,01 fica claramente pior.</a:t>
+              <a:t>Aprender do zero (ES e On-Policy) supera as duas políticas manuais do grupo em 0,014 a 0,032 de retorno médio por partida.</a:t>
             </a:r>
             <a:endParaRPr lang="en-US" sz="1800" dirty="0"/>
           </a:p>

</xml_diff>